<commit_message>
feat(night-r3b): Atelier premium 3-pak (DOCX/PPTX/XLSX samples) + DeckStyler §W5 decision-close fix
Co-Authored-By: Claude Opus 4.8 <noreply@anthropic.com>
</commit_message>
<xml_diff>
--- a/docs/qa/deliverables/runs/PPTX-STYLE-SAMPLE-after.pptx
+++ b/docs/qa/deliverables/runs/PPTX-STYLE-SAMPLE-after.pptx
@@ -2868,7 +2868,7 @@
         </p:nvSpPr>
         <p:spPr>
           <a:xfrm>
-            <a:off x="777240" y="1280160"/>
+            <a:off x="777240" y="1051560"/>
             <a:ext cx="7589520" cy="292608"/>
           </a:xfrm>
           <a:prstGeom prst="rect">
@@ -2893,7 +2893,7 @@
                 <a:ea typeface="Inter" pitchFamily="34" charset="-122"/>
                 <a:cs typeface="Inter" pitchFamily="34" charset="-120"/>
               </a:rPr>
-              <a:t>PREZENTACJA</a:t>
+              <a:t>DECYZJA</a:t>
             </a:r>
             <a:endParaRPr lang="en-US" sz="1200" dirty="0"/>
           </a:p>
@@ -2907,8 +2907,8 @@
         </p:nvSpPr>
         <p:spPr>
           <a:xfrm>
-            <a:off x="777240" y="1691640"/>
-            <a:ext cx="7589520" cy="1463040"/>
+            <a:off x="777240" y="1417320"/>
+            <a:ext cx="7589520" cy="1371600"/>
           </a:xfrm>
           <a:prstGeom prst="rect">
             <a:avLst/>
@@ -2924,12 +2924,12 @@
           <a:p>
             <a:pPr algn="l" indent="0" marL="0">
               <a:lnSpc>
-                <a:spcPct val="98000"/>
+                <a:spcPct val="100000"/>
               </a:lnSpc>
               <a:buNone/>
             </a:pPr>
             <a:r>
-              <a:rPr lang="en-US" sz="4000" b="1" dirty="0">
+              <a:rPr lang="en-US" sz="3000" b="1" dirty="0">
                 <a:solidFill>
                   <a:srgbClr val="FFFFFF"/>
                 </a:solidFill>
@@ -2937,9 +2937,9 @@
                 <a:ea typeface="Merriweather" pitchFamily="34" charset="-122"/>
                 <a:cs typeface="Merriweather" pitchFamily="34" charset="-120"/>
               </a:rPr>
-              <a:t>Dziękujemy</a:t>
-            </a:r>
-            <a:endParaRPr lang="en-US" sz="4000" dirty="0"/>
+              <a:t>Wdrożenie ATS skraca time-to-hire o 40% w dwa kwartały</a:t>
+            </a:r>
+            <a:endParaRPr lang="en-US" sz="3000" dirty="0"/>
           </a:p>
         </p:txBody>
       </p:sp>
@@ -2951,7 +2951,7 @@
         </p:nvSpPr>
         <p:spPr>
           <a:xfrm>
-            <a:off x="795528" y="3291840"/>
+            <a:off x="795528" y="2926080"/>
             <a:ext cx="1554480" cy="0"/>
           </a:xfrm>
           <a:prstGeom prst="line">
@@ -2974,8 +2974,8 @@
         </p:nvSpPr>
         <p:spPr>
           <a:xfrm>
-            <a:off x="777240" y="3456432"/>
-            <a:ext cx="7589520" cy="548640"/>
+            <a:off x="777240" y="3127248"/>
+            <a:ext cx="7589520" cy="1188720"/>
           </a:xfrm>
           <a:prstGeom prst="rect">
             <a:avLst/>
@@ -2984,14 +2984,19 @@
           <a:ln/>
         </p:spPr>
         <p:txBody>
-          <a:bodyPr wrap="square" rtlCol="0" anchor="t"/>
+          <a:bodyPr wrap="square" rtlCol="0" anchor="t">
+            <a:normAutofit/>
+          </a:bodyPr>
           <a:lstStyle/>
           <a:p>
             <a:pPr algn="l" indent="0" marL="0">
+              <a:lnSpc>
+                <a:spcPct val="105000"/>
+              </a:lnSpc>
               <a:buNone/>
             </a:pPr>
             <a:r>
-              <a:rPr lang="en-US" sz="1800" dirty="0">
+              <a:rPr lang="en-US" sz="1500" dirty="0">
                 <a:solidFill>
                   <a:srgbClr val="FFFFFF"/>
                 </a:solidFill>
@@ -2999,9 +3004,9 @@
                 <a:ea typeface="Inter" pitchFamily="34" charset="-122"/>
                 <a:cs typeface="Inter" pitchFamily="34" charset="-120"/>
               </a:rPr>
-              <a:t>ACME</a:t>
-            </a:r>
-            <a:endParaRPr lang="en-US" sz="1800" dirty="0"/>
+              <a:t>Czego oczekiwać: Rekomendujemy wdrożenie systemu ATS z ustandaryzowanym lejkiem, automatyczną selekcją CV i integracją kalendarza — pilotaż na jednym dziale, potem skalowanie.</a:t>
+            </a:r>
+            <a:endParaRPr lang="en-US" sz="1500" dirty="0"/>
           </a:p>
         </p:txBody>
       </p:sp>

</xml_diff>